<commit_message>
feat: implement multi-agent architectural assistant with FastAPI backend and Streamlit frontend
</commit_message>
<xml_diff>
--- a/T9998_VIT-Chennai_Rahi_Sanxipt_Mehta_Review1.pptx
+++ b/T9998_VIT-Chennai_Rahi_Sanxipt_Mehta_Review1.pptx
@@ -3989,7 +3989,7 @@
         <p:spPr>
           <a:xfrm>
             <a:off x="180236" y="1659822"/>
-            <a:ext cx="11428184" cy="3600986"/>
+            <a:ext cx="11428184" cy="2769989"/>
           </a:xfrm>
           <a:prstGeom prst="rect">
             <a:avLst/>
@@ -4010,6 +4010,7 @@
                 <a:solidFill>
                   <a:prstClr val="white"/>
                 </a:solidFill>
+                <a:latin typeface="Calibri (Body)"/>
                 <a:cs typeface="Calibri" panose="020F0502020204030204" pitchFamily="34" charset="0"/>
               </a:rPr>
               <a:t>Agentic AI Assistant for Architectural Design and Project Coordination</a:t>
@@ -4018,7 +4019,7 @@
               <a:solidFill>
                 <a:prstClr val="white"/>
               </a:solidFill>
-              <a:latin typeface="Frutiger 45 bold"/>
+              <a:latin typeface="Calibri (Body)"/>
               <a:cs typeface="Calibri" panose="020F0502020204030204" pitchFamily="34" charset="0"/>
             </a:endParaRPr>
           </a:p>
@@ -4036,24 +4037,9 @@
               <a:effectLst/>
               <a:uLnTx/>
               <a:uFillTx/>
-              <a:latin typeface="Frutiger 45 bold"/>
-              <a:ea typeface="+mn-ea"/>
+              <a:latin typeface="Calibri (Body)"/>
               <a:cs typeface="Calibri" panose="020F0502020204030204" pitchFamily="34" charset="0"/>
             </a:endParaRPr>
-          </a:p>
-          <a:p>
-            <a:pPr lvl="0" algn="ctr">
-              <a:defRPr/>
-            </a:pPr>
-            <a:r>
-              <a:rPr lang="en-US" sz="2400" b="1" dirty="0">
-                <a:solidFill>
-                  <a:prstClr val="white"/>
-                </a:solidFill>
-                <a:cs typeface="Calibri" panose="020F0502020204030204" pitchFamily="34" charset="0"/>
-              </a:rPr>
-              <a:t>Team Member</a:t>
-            </a:r>
           </a:p>
           <a:p>
             <a:pPr algn="ctr">
@@ -4064,36 +4050,26 @@
                 <a:solidFill>
                   <a:prstClr val="white"/>
                 </a:solidFill>
+                <a:latin typeface="Calibri (Body)"/>
                 <a:cs typeface="Calibri" panose="020F0502020204030204" pitchFamily="34" charset="0"/>
               </a:rPr>
               <a:t>Rahi Sanxipt Mehta</a:t>
             </a:r>
-            <a:endParaRPr lang="en-US" sz="5400" b="1" dirty="0">
-              <a:solidFill>
-                <a:prstClr val="white"/>
-              </a:solidFill>
-              <a:latin typeface="Frutiger 45 bold"/>
-              <a:cs typeface="Calibri" panose="020F0502020204030204" pitchFamily="34" charset="0"/>
-            </a:endParaRPr>
-          </a:p>
-          <a:p>
-            <a:pPr lvl="0" algn="ctr">
+          </a:p>
+          <a:p>
+            <a:pPr algn="ctr">
               <a:defRPr/>
             </a:pPr>
-            <a:endParaRPr kumimoji="0" lang="en-US" sz="5400" b="1" i="0" u="none" strike="noStrike" kern="1200" cap="none" spc="0" normalizeH="0" baseline="0" noProof="0" dirty="0">
-              <a:ln>
-                <a:noFill/>
-              </a:ln>
-              <a:solidFill>
-                <a:prstClr val="white"/>
-              </a:solidFill>
-              <a:effectLst/>
-              <a:uLnTx/>
-              <a:uFillTx/>
-              <a:latin typeface="Frutiger 45 bold"/>
-              <a:ea typeface="+mn-ea"/>
-              <a:cs typeface="Calibri" panose="020F0502020204030204" pitchFamily="34" charset="0"/>
-            </a:endParaRPr>
+            <a:r>
+              <a:rPr lang="en-US" sz="2400" b="1" dirty="0">
+                <a:solidFill>
+                  <a:prstClr val="white"/>
+                </a:solidFill>
+                <a:latin typeface="Calibri (Body)"/>
+                <a:cs typeface="Calibri" panose="020F0502020204030204" pitchFamily="34" charset="0"/>
+              </a:rPr>
+              <a:t>VIT Chennai</a:t>
+            </a:r>
           </a:p>
         </p:txBody>
       </p:sp>

</xml_diff>